<commit_message>
lec-11 Phase 6 final: icon fixes + iteration log (#127)
</commit_message>
<xml_diff>
--- a/library/lectures/lec-11/rendered/lec-11.pptx
+++ b/library/lectures/lec-11/rendered/lec-11.pptx
@@ -11771,92 +11771,33 @@
           </a:p>
         </p:txBody>
       </p:sp>
-      <p:sp>
-        <p:nvSpPr>
-          <p:cNvPr id="8" name="Rectangle 7"/>
-          <p:cNvSpPr/>
-          <p:nvPr/>
-        </p:nvSpPr>
-        <p:spPr>
-          <a:xfrm>
-            <a:off x="640080" y="2788920"/>
-            <a:ext cx="3337560" cy="1371600"/>
-          </a:xfrm>
-          <a:prstGeom prst="rect">
-            <a:avLst/>
-          </a:prstGeom>
-          <a:solidFill>
-            <a:srgbClr val="E5EAF0"/>
-          </a:solidFill>
-          <a:ln>
-            <a:noFill/>
-          </a:ln>
-          <a:effectLst/>
-        </p:spPr>
-        <p:style>
-          <a:lnRef idx="1">
-            <a:schemeClr val="accent1"/>
-          </a:lnRef>
-          <a:fillRef idx="3">
-            <a:schemeClr val="accent1"/>
-          </a:fillRef>
-          <a:effectRef idx="2">
-            <a:schemeClr val="accent1"/>
-          </a:effectRef>
-          <a:fontRef idx="minor">
-            <a:schemeClr val="lt1"/>
-          </a:fontRef>
-        </p:style>
-        <p:txBody>
-          <a:bodyPr rtlCol="0" anchor="ctr"/>
-          <a:lstStyle/>
-          <a:p>
-            <a:pPr algn="ctr"/>
-          </a:p>
-        </p:txBody>
-      </p:sp>
+      <p:pic>
+        <p:nvPicPr>
+          <p:cNvPr id="8" name="Picture 7" descr="factory.png"/>
+          <p:cNvPicPr>
+            <a:picLocks noChangeAspect="1"/>
+          </p:cNvPicPr>
+          <p:nvPr/>
+        </p:nvPicPr>
+        <p:blipFill>
+          <a:blip r:embed="rId2"/>
+          <a:stretch>
+            <a:fillRect/>
+          </a:stretch>
+        </p:blipFill>
+        <p:spPr>
+          <a:xfrm>
+            <a:off x="1760219" y="2880360"/>
+            <a:ext cx="1097280" cy="1097280"/>
+          </a:xfrm>
+          <a:prstGeom prst="rect">
+            <a:avLst/>
+          </a:prstGeom>
+        </p:spPr>
+      </p:pic>
       <p:sp>
         <p:nvSpPr>
           <p:cNvPr id="9" name="TextBox 8"/>
-          <p:cNvSpPr txBox="1"/>
-          <p:nvPr/>
-        </p:nvSpPr>
-        <p:spPr>
-          <a:xfrm>
-            <a:off x="640080" y="3383280"/>
-            <a:ext cx="3337560" cy="365760"/>
-          </a:xfrm>
-          <a:prstGeom prst="rect">
-            <a:avLst/>
-          </a:prstGeom>
-          <a:noFill/>
-        </p:spPr>
-        <p:txBody>
-          <a:bodyPr wrap="square" lIns="0" rIns="0" tIns="0" bIns="0" anchor="t">
-            <a:spAutoFit/>
-          </a:bodyPr>
-          <a:lstStyle/>
-          <a:p>
-            <a:pPr algn="ctr">
-              <a:lnSpc>
-                <a:spcPct val="115000"/>
-              </a:lnSpc>
-            </a:pPr>
-            <a:r>
-              <a:rPr sz="1100" b="0" i="0">
-                <a:solidFill>
-                  <a:srgbClr val="6B7685"/>
-                </a:solidFill>
-                <a:latin typeface="Arial"/>
-              </a:rPr>
-              <a:t>[фото]</a:t>
-            </a:r>
-          </a:p>
-        </p:txBody>
-      </p:sp>
-      <p:sp>
-        <p:nvSpPr>
-          <p:cNvPr id="10" name="TextBox 9"/>
           <p:cNvSpPr txBox="1"/>
           <p:nvPr/>
         </p:nvSpPr>
@@ -11895,7 +11836,7 @@
       </p:sp>
       <p:sp>
         <p:nvSpPr>
-          <p:cNvPr id="11" name="TextBox 10"/>
+          <p:cNvPr id="10" name="TextBox 9"/>
           <p:cNvSpPr txBox="1"/>
           <p:nvPr/>
         </p:nvSpPr>
@@ -11934,7 +11875,7 @@
       </p:sp>
       <p:sp>
         <p:nvSpPr>
-          <p:cNvPr id="12" name="TextBox 11"/>
+          <p:cNvPr id="11" name="TextBox 10"/>
           <p:cNvSpPr txBox="1"/>
           <p:nvPr/>
         </p:nvSpPr>
@@ -11973,7 +11914,7 @@
       </p:sp>
       <p:sp>
         <p:nvSpPr>
-          <p:cNvPr id="13" name="Rounded Rectangle 12"/>
+          <p:cNvPr id="12" name="Rounded Rectangle 11"/>
           <p:cNvSpPr/>
           <p:nvPr/>
         </p:nvSpPr>
@@ -12021,7 +11962,7 @@
       </p:sp>
       <p:sp>
         <p:nvSpPr>
-          <p:cNvPr id="14" name="TextBox 13"/>
+          <p:cNvPr id="13" name="TextBox 12"/>
           <p:cNvSpPr txBox="1"/>
           <p:nvPr/>
         </p:nvSpPr>
@@ -12060,7 +12001,7 @@
       </p:sp>
       <p:sp>
         <p:nvSpPr>
-          <p:cNvPr id="15" name="Rounded Rectangle 14"/>
+          <p:cNvPr id="14" name="Rounded Rectangle 13"/>
           <p:cNvSpPr/>
           <p:nvPr/>
         </p:nvSpPr>
@@ -12108,7 +12049,7 @@
       </p:sp>
       <p:sp>
         <p:nvSpPr>
-          <p:cNvPr id="16" name="Rectangle 15"/>
+          <p:cNvPr id="15" name="Rectangle 14"/>
           <p:cNvSpPr/>
           <p:nvPr/>
         </p:nvSpPr>
@@ -12152,7 +12093,7 @@
       </p:sp>
       <p:sp>
         <p:nvSpPr>
-          <p:cNvPr id="17" name="TextBox 16"/>
+          <p:cNvPr id="16" name="TextBox 15"/>
           <p:cNvSpPr txBox="1"/>
           <p:nvPr/>
         </p:nvSpPr>
@@ -12191,7 +12132,7 @@
       </p:sp>
       <p:sp>
         <p:nvSpPr>
-          <p:cNvPr id="18" name="TextBox 17"/>
+          <p:cNvPr id="17" name="TextBox 16"/>
           <p:cNvSpPr txBox="1"/>
           <p:nvPr/>
         </p:nvSpPr>
@@ -12230,14 +12171,14 @@
       </p:sp>
       <p:pic>
         <p:nvPicPr>
-          <p:cNvPr id="19" name="Picture 18" descr="s14-tsmc.jpg"/>
+          <p:cNvPr id="18" name="Picture 17" descr="s14-tsmc.jpg"/>
           <p:cNvPicPr>
             <a:picLocks noChangeAspect="1"/>
           </p:cNvPicPr>
           <p:nvPr/>
         </p:nvPicPr>
         <p:blipFill>
-          <a:blip r:embed="rId2"/>
+          <a:blip r:embed="rId3"/>
           <a:stretch>
             <a:fillRect/>
           </a:stretch>
@@ -12254,7 +12195,7 @@
       </p:pic>
       <p:sp>
         <p:nvSpPr>
-          <p:cNvPr id="20" name="TextBox 19"/>
+          <p:cNvPr id="19" name="TextBox 18"/>
           <p:cNvSpPr txBox="1"/>
           <p:nvPr/>
         </p:nvSpPr>
@@ -12293,7 +12234,7 @@
       </p:sp>
       <p:sp>
         <p:nvSpPr>
-          <p:cNvPr id="21" name="TextBox 20"/>
+          <p:cNvPr id="20" name="TextBox 19"/>
           <p:cNvSpPr txBox="1"/>
           <p:nvPr/>
         </p:nvSpPr>
@@ -12332,7 +12273,7 @@
       </p:sp>
       <p:sp>
         <p:nvSpPr>
-          <p:cNvPr id="22" name="TextBox 21"/>
+          <p:cNvPr id="21" name="TextBox 20"/>
           <p:cNvSpPr txBox="1"/>
           <p:nvPr/>
         </p:nvSpPr>
@@ -12371,7 +12312,7 @@
       </p:sp>
       <p:sp>
         <p:nvSpPr>
-          <p:cNvPr id="23" name="Rounded Rectangle 22"/>
+          <p:cNvPr id="22" name="Rounded Rectangle 21"/>
           <p:cNvSpPr/>
           <p:nvPr/>
         </p:nvSpPr>
@@ -12419,7 +12360,7 @@
       </p:sp>
       <p:sp>
         <p:nvSpPr>
-          <p:cNvPr id="24" name="TextBox 23"/>
+          <p:cNvPr id="23" name="TextBox 22"/>
           <p:cNvSpPr txBox="1"/>
           <p:nvPr/>
         </p:nvSpPr>
@@ -12458,7 +12399,7 @@
       </p:sp>
       <p:sp>
         <p:nvSpPr>
-          <p:cNvPr id="25" name="Rounded Rectangle 24"/>
+          <p:cNvPr id="24" name="Rounded Rectangle 23"/>
           <p:cNvSpPr/>
           <p:nvPr/>
         </p:nvSpPr>
@@ -12506,7 +12447,7 @@
       </p:sp>
       <p:sp>
         <p:nvSpPr>
-          <p:cNvPr id="26" name="Rectangle 25"/>
+          <p:cNvPr id="25" name="Rectangle 24"/>
           <p:cNvSpPr/>
           <p:nvPr/>
         </p:nvSpPr>
@@ -12550,7 +12491,7 @@
       </p:sp>
       <p:sp>
         <p:nvSpPr>
-          <p:cNvPr id="27" name="TextBox 26"/>
+          <p:cNvPr id="26" name="TextBox 25"/>
           <p:cNvSpPr txBox="1"/>
           <p:nvPr/>
         </p:nvSpPr>
@@ -12589,7 +12530,7 @@
       </p:sp>
       <p:sp>
         <p:nvSpPr>
-          <p:cNvPr id="28" name="TextBox 27"/>
+          <p:cNvPr id="27" name="TextBox 26"/>
           <p:cNvSpPr txBox="1"/>
           <p:nvPr/>
         </p:nvSpPr>
@@ -12626,92 +12567,33 @@
           </a:p>
         </p:txBody>
       </p:sp>
-      <p:sp>
-        <p:nvSpPr>
-          <p:cNvPr id="29" name="Rectangle 28"/>
-          <p:cNvSpPr/>
-          <p:nvPr/>
-        </p:nvSpPr>
-        <p:spPr>
-          <a:xfrm>
-            <a:off x="8229599" y="2788920"/>
-            <a:ext cx="3337560" cy="1371600"/>
-          </a:xfrm>
-          <a:prstGeom prst="rect">
-            <a:avLst/>
-          </a:prstGeom>
-          <a:solidFill>
-            <a:srgbClr val="E5EAF0"/>
-          </a:solidFill>
-          <a:ln>
-            <a:noFill/>
-          </a:ln>
-          <a:effectLst/>
-        </p:spPr>
-        <p:style>
-          <a:lnRef idx="1">
-            <a:schemeClr val="accent1"/>
-          </a:lnRef>
-          <a:fillRef idx="3">
-            <a:schemeClr val="accent1"/>
-          </a:fillRef>
-          <a:effectRef idx="2">
-            <a:schemeClr val="accent1"/>
-          </a:effectRef>
-          <a:fontRef idx="minor">
-            <a:schemeClr val="lt1"/>
-          </a:fontRef>
-        </p:style>
-        <p:txBody>
-          <a:bodyPr rtlCol="0" anchor="ctr"/>
-          <a:lstStyle/>
-          <a:p>
-            <a:pPr algn="ctr"/>
-          </a:p>
-        </p:txBody>
-      </p:sp>
-      <p:sp>
-        <p:nvSpPr>
-          <p:cNvPr id="30" name="TextBox 29"/>
-          <p:cNvSpPr txBox="1"/>
-          <p:nvPr/>
-        </p:nvSpPr>
-        <p:spPr>
-          <a:xfrm>
-            <a:off x="8229599" y="3383280"/>
-            <a:ext cx="3337560" cy="365760"/>
-          </a:xfrm>
-          <a:prstGeom prst="rect">
-            <a:avLst/>
-          </a:prstGeom>
-          <a:noFill/>
-        </p:spPr>
-        <p:txBody>
-          <a:bodyPr wrap="square" lIns="0" rIns="0" tIns="0" bIns="0" anchor="t">
-            <a:spAutoFit/>
-          </a:bodyPr>
-          <a:lstStyle/>
-          <a:p>
-            <a:pPr algn="ctr">
-              <a:lnSpc>
-                <a:spcPct val="115000"/>
-              </a:lnSpc>
-            </a:pPr>
-            <a:r>
-              <a:rPr sz="1100" b="0" i="0">
-                <a:solidFill>
-                  <a:srgbClr val="6B7685"/>
-                </a:solidFill>
-                <a:latin typeface="Arial"/>
-              </a:rPr>
-              <a:t>[фото]</a:t>
-            </a:r>
-          </a:p>
-        </p:txBody>
-      </p:sp>
-      <p:sp>
-        <p:nvSpPr>
-          <p:cNvPr id="31" name="TextBox 30"/>
+      <p:pic>
+        <p:nvPicPr>
+          <p:cNvPr id="28" name="Picture 27" descr="shield-check.png"/>
+          <p:cNvPicPr>
+            <a:picLocks noChangeAspect="1"/>
+          </p:cNvPicPr>
+          <p:nvPr/>
+        </p:nvPicPr>
+        <p:blipFill>
+          <a:blip r:embed="rId4"/>
+          <a:stretch>
+            <a:fillRect/>
+          </a:stretch>
+        </p:blipFill>
+        <p:spPr>
+          <a:xfrm>
+            <a:off x="9349740" y="2880360"/>
+            <a:ext cx="1097280" cy="1097280"/>
+          </a:xfrm>
+          <a:prstGeom prst="rect">
+            <a:avLst/>
+          </a:prstGeom>
+        </p:spPr>
+      </p:pic>
+      <p:sp>
+        <p:nvSpPr>
+          <p:cNvPr id="29" name="TextBox 28"/>
           <p:cNvSpPr txBox="1"/>
           <p:nvPr/>
         </p:nvSpPr>
@@ -12750,7 +12632,7 @@
       </p:sp>
       <p:sp>
         <p:nvSpPr>
-          <p:cNvPr id="32" name="TextBox 31"/>
+          <p:cNvPr id="30" name="TextBox 29"/>
           <p:cNvSpPr txBox="1"/>
           <p:nvPr/>
         </p:nvSpPr>
@@ -12789,7 +12671,7 @@
       </p:sp>
       <p:sp>
         <p:nvSpPr>
-          <p:cNvPr id="33" name="TextBox 32"/>
+          <p:cNvPr id="31" name="TextBox 30"/>
           <p:cNvSpPr txBox="1"/>
           <p:nvPr/>
         </p:nvSpPr>
@@ -12828,7 +12710,7 @@
       </p:sp>
       <p:sp>
         <p:nvSpPr>
-          <p:cNvPr id="34" name="Rounded Rectangle 33"/>
+          <p:cNvPr id="32" name="Rounded Rectangle 31"/>
           <p:cNvSpPr/>
           <p:nvPr/>
         </p:nvSpPr>
@@ -12876,7 +12758,7 @@
       </p:sp>
       <p:sp>
         <p:nvSpPr>
-          <p:cNvPr id="35" name="TextBox 34"/>
+          <p:cNvPr id="33" name="TextBox 32"/>
           <p:cNvSpPr txBox="1"/>
           <p:nvPr/>
         </p:nvSpPr>
@@ -12915,7 +12797,7 @@
       </p:sp>
       <p:sp>
         <p:nvSpPr>
-          <p:cNvPr id="36" name="Rounded Rectangle 35"/>
+          <p:cNvPr id="34" name="Rounded Rectangle 33"/>
           <p:cNvSpPr/>
           <p:nvPr/>
         </p:nvSpPr>
@@ -12963,7 +12845,7 @@
       </p:sp>
       <p:sp>
         <p:nvSpPr>
-          <p:cNvPr id="37" name="TextBox 36"/>
+          <p:cNvPr id="35" name="TextBox 34"/>
           <p:cNvSpPr txBox="1"/>
           <p:nvPr/>
         </p:nvSpPr>
@@ -13002,7 +12884,7 @@
       </p:sp>
       <p:sp>
         <p:nvSpPr>
-          <p:cNvPr id="38" name="TextBox 37"/>
+          <p:cNvPr id="36" name="TextBox 35"/>
           <p:cNvSpPr txBox="1"/>
           <p:nvPr/>
         </p:nvSpPr>
@@ -15232,92 +15114,33 @@
           </a:p>
         </p:txBody>
       </p:sp>
-      <p:sp>
-        <p:nvSpPr>
-          <p:cNvPr id="8" name="Rectangle 7"/>
-          <p:cNvSpPr/>
-          <p:nvPr/>
-        </p:nvSpPr>
-        <p:spPr>
-          <a:xfrm>
-            <a:off x="731520" y="2834639"/>
-            <a:ext cx="3154679" cy="1828800"/>
-          </a:xfrm>
-          <a:prstGeom prst="rect">
-            <a:avLst/>
-          </a:prstGeom>
-          <a:solidFill>
-            <a:srgbClr val="E5EAF0"/>
-          </a:solidFill>
-          <a:ln>
-            <a:noFill/>
-          </a:ln>
-          <a:effectLst/>
-        </p:spPr>
-        <p:style>
-          <a:lnRef idx="1">
-            <a:schemeClr val="accent1"/>
-          </a:lnRef>
-          <a:fillRef idx="3">
-            <a:schemeClr val="accent1"/>
-          </a:fillRef>
-          <a:effectRef idx="2">
-            <a:schemeClr val="accent1"/>
-          </a:effectRef>
-          <a:fontRef idx="minor">
-            <a:schemeClr val="lt1"/>
-          </a:fontRef>
-        </p:style>
-        <p:txBody>
-          <a:bodyPr rtlCol="0" anchor="ctr"/>
-          <a:lstStyle/>
-          <a:p>
-            <a:pPr algn="ctr"/>
-          </a:p>
-        </p:txBody>
-      </p:sp>
+      <p:pic>
+        <p:nvPicPr>
+          <p:cNvPr id="8" name="Picture 7" descr="cog.png"/>
+          <p:cNvPicPr>
+            <a:picLocks noChangeAspect="1"/>
+          </p:cNvPicPr>
+          <p:nvPr/>
+        </p:nvPicPr>
+        <p:blipFill>
+          <a:blip r:embed="rId2"/>
+          <a:stretch>
+            <a:fillRect/>
+          </a:stretch>
+        </p:blipFill>
+        <p:spPr>
+          <a:xfrm>
+            <a:off x="1485900" y="2880360"/>
+            <a:ext cx="1645920" cy="1645920"/>
+          </a:xfrm>
+          <a:prstGeom prst="rect">
+            <a:avLst/>
+          </a:prstGeom>
+        </p:spPr>
+      </p:pic>
       <p:sp>
         <p:nvSpPr>
           <p:cNvPr id="9" name="TextBox 8"/>
-          <p:cNvSpPr txBox="1"/>
-          <p:nvPr/>
-        </p:nvSpPr>
-        <p:spPr>
-          <a:xfrm>
-            <a:off x="731520" y="3383280"/>
-            <a:ext cx="3154679" cy="457200"/>
-          </a:xfrm>
-          <a:prstGeom prst="rect">
-            <a:avLst/>
-          </a:prstGeom>
-          <a:noFill/>
-        </p:spPr>
-        <p:txBody>
-          <a:bodyPr wrap="square" lIns="0" rIns="0" tIns="0" bIns="0" anchor="t">
-            <a:spAutoFit/>
-          </a:bodyPr>
-          <a:lstStyle/>
-          <a:p>
-            <a:pPr algn="ctr">
-              <a:lnSpc>
-                <a:spcPct val="115000"/>
-              </a:lnSpc>
-            </a:pPr>
-            <a:r>
-              <a:rPr sz="1100" b="0" i="0">
-                <a:solidFill>
-                  <a:srgbClr val="6B7685"/>
-                </a:solidFill>
-                <a:latin typeface="Arial"/>
-              </a:rPr>
-              <a:t>[фото]</a:t>
-            </a:r>
-          </a:p>
-        </p:txBody>
-      </p:sp>
-      <p:sp>
-        <p:nvSpPr>
-          <p:cNvPr id="10" name="TextBox 9"/>
           <p:cNvSpPr txBox="1"/>
           <p:nvPr/>
         </p:nvSpPr>
@@ -15357,7 +15180,7 @@
       </p:sp>
       <p:sp>
         <p:nvSpPr>
-          <p:cNvPr id="11" name="Rounded Rectangle 10"/>
+          <p:cNvPr id="10" name="Rounded Rectangle 9"/>
           <p:cNvSpPr/>
           <p:nvPr/>
         </p:nvSpPr>
@@ -15405,7 +15228,7 @@
       </p:sp>
       <p:sp>
         <p:nvSpPr>
-          <p:cNvPr id="12" name="Rectangle 11"/>
+          <p:cNvPr id="11" name="Rectangle 10"/>
           <p:cNvSpPr/>
           <p:nvPr/>
         </p:nvSpPr>
@@ -15449,7 +15272,7 @@
       </p:sp>
       <p:sp>
         <p:nvSpPr>
-          <p:cNvPr id="13" name="TextBox 12"/>
+          <p:cNvPr id="12" name="TextBox 11"/>
           <p:cNvSpPr txBox="1"/>
           <p:nvPr/>
         </p:nvSpPr>
@@ -15488,7 +15311,7 @@
       </p:sp>
       <p:sp>
         <p:nvSpPr>
-          <p:cNvPr id="14" name="TextBox 13"/>
+          <p:cNvPr id="13" name="TextBox 12"/>
           <p:cNvSpPr txBox="1"/>
           <p:nvPr/>
         </p:nvSpPr>
@@ -15525,92 +15348,33 @@
           </a:p>
         </p:txBody>
       </p:sp>
-      <p:sp>
-        <p:nvSpPr>
-          <p:cNvPr id="15" name="Rectangle 14"/>
-          <p:cNvSpPr/>
-          <p:nvPr/>
-        </p:nvSpPr>
-        <p:spPr>
-          <a:xfrm>
-            <a:off x="4526279" y="2834639"/>
-            <a:ext cx="3154679" cy="1828800"/>
-          </a:xfrm>
-          <a:prstGeom prst="rect">
-            <a:avLst/>
-          </a:prstGeom>
-          <a:solidFill>
-            <a:srgbClr val="E5EAF0"/>
-          </a:solidFill>
-          <a:ln>
-            <a:noFill/>
-          </a:ln>
-          <a:effectLst/>
-        </p:spPr>
-        <p:style>
-          <a:lnRef idx="1">
-            <a:schemeClr val="accent1"/>
-          </a:lnRef>
-          <a:fillRef idx="3">
-            <a:schemeClr val="accent1"/>
-          </a:fillRef>
-          <a:effectRef idx="2">
-            <a:schemeClr val="accent1"/>
-          </a:effectRef>
-          <a:fontRef idx="minor">
-            <a:schemeClr val="lt1"/>
-          </a:fontRef>
-        </p:style>
-        <p:txBody>
-          <a:bodyPr rtlCol="0" anchor="ctr"/>
-          <a:lstStyle/>
-          <a:p>
-            <a:pPr algn="ctr"/>
-          </a:p>
-        </p:txBody>
-      </p:sp>
-      <p:sp>
-        <p:nvSpPr>
-          <p:cNvPr id="16" name="TextBox 15"/>
-          <p:cNvSpPr txBox="1"/>
-          <p:nvPr/>
-        </p:nvSpPr>
-        <p:spPr>
-          <a:xfrm>
-            <a:off x="4526279" y="3383280"/>
-            <a:ext cx="3154679" cy="457200"/>
-          </a:xfrm>
-          <a:prstGeom prst="rect">
-            <a:avLst/>
-          </a:prstGeom>
-          <a:noFill/>
-        </p:spPr>
-        <p:txBody>
-          <a:bodyPr wrap="square" lIns="0" rIns="0" tIns="0" bIns="0" anchor="t">
-            <a:spAutoFit/>
-          </a:bodyPr>
-          <a:lstStyle/>
-          <a:p>
-            <a:pPr algn="ctr">
-              <a:lnSpc>
-                <a:spcPct val="115000"/>
-              </a:lnSpc>
-            </a:pPr>
-            <a:r>
-              <a:rPr sz="1100" b="0" i="0">
-                <a:solidFill>
-                  <a:srgbClr val="6B7685"/>
-                </a:solidFill>
-                <a:latin typeface="Arial"/>
-              </a:rPr>
-              <a:t>[фото]</a:t>
-            </a:r>
-          </a:p>
-        </p:txBody>
-      </p:sp>
-      <p:sp>
-        <p:nvSpPr>
-          <p:cNvPr id="17" name="TextBox 16"/>
+      <p:pic>
+        <p:nvPicPr>
+          <p:cNvPr id="14" name="Picture 13" descr="users.png"/>
+          <p:cNvPicPr>
+            <a:picLocks noChangeAspect="1"/>
+          </p:cNvPicPr>
+          <p:nvPr/>
+        </p:nvPicPr>
+        <p:blipFill>
+          <a:blip r:embed="rId3"/>
+          <a:stretch>
+            <a:fillRect/>
+          </a:stretch>
+        </p:blipFill>
+        <p:spPr>
+          <a:xfrm>
+            <a:off x="5280659" y="2880360"/>
+            <a:ext cx="1645920" cy="1645920"/>
+          </a:xfrm>
+          <a:prstGeom prst="rect">
+            <a:avLst/>
+          </a:prstGeom>
+        </p:spPr>
+      </p:pic>
+      <p:sp>
+        <p:nvSpPr>
+          <p:cNvPr id="15" name="TextBox 14"/>
           <p:cNvSpPr txBox="1"/>
           <p:nvPr/>
         </p:nvSpPr>
@@ -15650,7 +15414,7 @@
       </p:sp>
       <p:sp>
         <p:nvSpPr>
-          <p:cNvPr id="18" name="Rounded Rectangle 17"/>
+          <p:cNvPr id="16" name="Rounded Rectangle 15"/>
           <p:cNvSpPr/>
           <p:nvPr/>
         </p:nvSpPr>
@@ -15698,7 +15462,7 @@
       </p:sp>
       <p:sp>
         <p:nvSpPr>
-          <p:cNvPr id="19" name="Rectangle 18"/>
+          <p:cNvPr id="17" name="Rectangle 16"/>
           <p:cNvSpPr/>
           <p:nvPr/>
         </p:nvSpPr>
@@ -15742,7 +15506,7 @@
       </p:sp>
       <p:sp>
         <p:nvSpPr>
-          <p:cNvPr id="20" name="TextBox 19"/>
+          <p:cNvPr id="18" name="TextBox 17"/>
           <p:cNvSpPr txBox="1"/>
           <p:nvPr/>
         </p:nvSpPr>
@@ -15781,7 +15545,7 @@
       </p:sp>
       <p:sp>
         <p:nvSpPr>
-          <p:cNvPr id="21" name="TextBox 20"/>
+          <p:cNvPr id="19" name="TextBox 18"/>
           <p:cNvSpPr txBox="1"/>
           <p:nvPr/>
         </p:nvSpPr>
@@ -15818,92 +15582,33 @@
           </a:p>
         </p:txBody>
       </p:sp>
-      <p:sp>
-        <p:nvSpPr>
-          <p:cNvPr id="22" name="Rectangle 21"/>
-          <p:cNvSpPr/>
-          <p:nvPr/>
-        </p:nvSpPr>
-        <p:spPr>
-          <a:xfrm>
-            <a:off x="8321040" y="2834639"/>
-            <a:ext cx="3154679" cy="1828800"/>
-          </a:xfrm>
-          <a:prstGeom prst="rect">
-            <a:avLst/>
-          </a:prstGeom>
-          <a:solidFill>
-            <a:srgbClr val="E5EAF0"/>
-          </a:solidFill>
-          <a:ln>
-            <a:noFill/>
-          </a:ln>
-          <a:effectLst/>
-        </p:spPr>
-        <p:style>
-          <a:lnRef idx="1">
-            <a:schemeClr val="accent1"/>
-          </a:lnRef>
-          <a:fillRef idx="3">
-            <a:schemeClr val="accent1"/>
-          </a:fillRef>
-          <a:effectRef idx="2">
-            <a:schemeClr val="accent1"/>
-          </a:effectRef>
-          <a:fontRef idx="minor">
-            <a:schemeClr val="lt1"/>
-          </a:fontRef>
-        </p:style>
-        <p:txBody>
-          <a:bodyPr rtlCol="0" anchor="ctr"/>
-          <a:lstStyle/>
-          <a:p>
-            <a:pPr algn="ctr"/>
-          </a:p>
-        </p:txBody>
-      </p:sp>
-      <p:sp>
-        <p:nvSpPr>
-          <p:cNvPr id="23" name="TextBox 22"/>
-          <p:cNvSpPr txBox="1"/>
-          <p:nvPr/>
-        </p:nvSpPr>
-        <p:spPr>
-          <a:xfrm>
-            <a:off x="8321040" y="3383280"/>
-            <a:ext cx="3154679" cy="457200"/>
-          </a:xfrm>
-          <a:prstGeom prst="rect">
-            <a:avLst/>
-          </a:prstGeom>
-          <a:noFill/>
-        </p:spPr>
-        <p:txBody>
-          <a:bodyPr wrap="square" lIns="0" rIns="0" tIns="0" bIns="0" anchor="t">
-            <a:spAutoFit/>
-          </a:bodyPr>
-          <a:lstStyle/>
-          <a:p>
-            <a:pPr algn="ctr">
-              <a:lnSpc>
-                <a:spcPct val="115000"/>
-              </a:lnSpc>
-            </a:pPr>
-            <a:r>
-              <a:rPr sz="1100" b="0" i="0">
-                <a:solidFill>
-                  <a:srgbClr val="6B7685"/>
-                </a:solidFill>
-                <a:latin typeface="Arial"/>
-              </a:rPr>
-              <a:t>[фото]</a:t>
-            </a:r>
-          </a:p>
-        </p:txBody>
-      </p:sp>
-      <p:sp>
-        <p:nvSpPr>
-          <p:cNvPr id="24" name="TextBox 23"/>
+      <p:pic>
+        <p:nvPicPr>
+          <p:cNvPr id="20" name="Picture 19" descr="wrench.png"/>
+          <p:cNvPicPr>
+            <a:picLocks noChangeAspect="1"/>
+          </p:cNvPicPr>
+          <p:nvPr/>
+        </p:nvPicPr>
+        <p:blipFill>
+          <a:blip r:embed="rId4"/>
+          <a:stretch>
+            <a:fillRect/>
+          </a:stretch>
+        </p:blipFill>
+        <p:spPr>
+          <a:xfrm>
+            <a:off x="9075419" y="2880360"/>
+            <a:ext cx="1645920" cy="1645920"/>
+          </a:xfrm>
+          <a:prstGeom prst="rect">
+            <a:avLst/>
+          </a:prstGeom>
+        </p:spPr>
+      </p:pic>
+      <p:sp>
+        <p:nvSpPr>
+          <p:cNvPr id="21" name="TextBox 20"/>
           <p:cNvSpPr txBox="1"/>
           <p:nvPr/>
         </p:nvSpPr>
@@ -15943,7 +15648,7 @@
       </p:sp>
       <p:sp>
         <p:nvSpPr>
-          <p:cNvPr id="25" name="Rounded Rectangle 24"/>
+          <p:cNvPr id="22" name="Rounded Rectangle 21"/>
           <p:cNvSpPr/>
           <p:nvPr/>
         </p:nvSpPr>
@@ -15991,7 +15696,7 @@
       </p:sp>
       <p:sp>
         <p:nvSpPr>
-          <p:cNvPr id="26" name="TextBox 25"/>
+          <p:cNvPr id="23" name="TextBox 22"/>
           <p:cNvSpPr txBox="1"/>
           <p:nvPr/>
         </p:nvSpPr>
@@ -22042,50 +21747,30 @@
           </a:p>
         </p:txBody>
       </p:sp>
-      <p:sp>
-        <p:nvSpPr>
-          <p:cNvPr id="13" name="Rectangle 12"/>
-          <p:cNvSpPr/>
-          <p:nvPr/>
-        </p:nvSpPr>
-        <p:spPr>
-          <a:xfrm>
-            <a:off x="6309360" y="2240280"/>
-            <a:ext cx="5239512" cy="2011680"/>
-          </a:xfrm>
-          <a:prstGeom prst="rect">
-            <a:avLst/>
-          </a:prstGeom>
-          <a:solidFill>
-            <a:srgbClr val="E5EAF0"/>
-          </a:solidFill>
-          <a:ln>
-            <a:noFill/>
-          </a:ln>
-          <a:effectLst/>
-        </p:spPr>
-        <p:style>
-          <a:lnRef idx="1">
-            <a:schemeClr val="accent1"/>
-          </a:lnRef>
-          <a:fillRef idx="3">
-            <a:schemeClr val="accent1"/>
-          </a:fillRef>
-          <a:effectRef idx="2">
-            <a:schemeClr val="accent1"/>
-          </a:effectRef>
-          <a:fontRef idx="minor">
-            <a:schemeClr val="lt1"/>
-          </a:fontRef>
-        </p:style>
-        <p:txBody>
-          <a:bodyPr rtlCol="0" anchor="ctr"/>
-          <a:lstStyle/>
-          <a:p>
-            <a:pPr algn="ctr"/>
-          </a:p>
-        </p:txBody>
-      </p:sp>
+      <p:pic>
+        <p:nvPicPr>
+          <p:cNvPr id="13" name="Picture 12" descr="pill.png"/>
+          <p:cNvPicPr>
+            <a:picLocks noChangeAspect="1"/>
+          </p:cNvPicPr>
+          <p:nvPr/>
+        </p:nvPicPr>
+        <p:blipFill>
+          <a:blip r:embed="rId3"/>
+          <a:stretch>
+            <a:fillRect/>
+          </a:stretch>
+        </p:blipFill>
+        <p:spPr>
+          <a:xfrm>
+            <a:off x="8229600" y="2331720"/>
+            <a:ext cx="1371600" cy="1371600"/>
+          </a:xfrm>
+          <a:prstGeom prst="rect">
+            <a:avLst/>
+          </a:prstGeom>
+        </p:spPr>
+      </p:pic>
       <p:sp>
         <p:nvSpPr>
           <p:cNvPr id="14" name="TextBox 13"/>
@@ -22094,16 +21779,16 @@
         </p:nvSpPr>
         <p:spPr>
           <a:xfrm>
-            <a:off x="6309360" y="3108960"/>
-            <a:ext cx="5239512" cy="457200"/>
-          </a:xfrm>
-          <a:prstGeom prst="rect">
-            <a:avLst/>
-          </a:prstGeom>
-          <a:noFill/>
-        </p:spPr>
-        <p:txBody>
-          <a:bodyPr wrap="square" lIns="0" rIns="0" tIns="0" bIns="0" anchor="ctr">
+            <a:off x="6309360" y="3749039"/>
+            <a:ext cx="5239512" cy="365760"/>
+          </a:xfrm>
+          <a:prstGeom prst="rect">
+            <a:avLst/>
+          </a:prstGeom>
+          <a:noFill/>
+        </p:spPr>
+        <p:txBody>
+          <a:bodyPr wrap="square" lIns="0" rIns="0" tIns="0" bIns="0" anchor="t">
             <a:spAutoFit/>
           </a:bodyPr>
           <a:lstStyle/>
@@ -22114,13 +21799,13 @@
               </a:lnSpc>
             </a:pPr>
             <a:r>
-              <a:rPr sz="1200" b="0" i="0">
-                <a:solidFill>
-                  <a:srgbClr val="6B7685"/>
-                </a:solidFill>
-                <a:latin typeface="Arial"/>
-              </a:rPr>
-              <a:t>[Pfizer plant photo]</a:t>
+              <a:rPr sz="1100" b="0" i="1">
+                <a:solidFill>
+                  <a:srgbClr val="4A556B"/>
+                </a:solidFill>
+                <a:latin typeface="Arial"/>
+              </a:rPr>
+              <a:t>GenAI на AWS Bedrock + SageMaker</a:t>
             </a:r>
           </a:p>
         </p:txBody>

</xml_diff>

<commit_message>
lec-11 Phase 11.5: align s34c brewery numbers к chapter canonical 30K/700K/3.5K/30d (#127)
P0 from pre-USER-GATE C walkthrough: slide s34c had drift numbers
(60K/h, >1M/day, 5K defects, 2-3 weeks) inconsistent with chapter §4.3c
+ speech §4 v2 canonical (30K/h, ~700K/day, 3.5K defects, 30 days).

Edits:
- s34c-brewery-cv-qc-pass.md: assertion + narrative + step 1 + step 3 + speaker notes
- build_lec11_part2.py: card body for ШАГ 1 (30 000/h) и ШАГ 3 (700K/3.5K/30d)
- Re-rendered PPTX + PDF

Independent verify (pptx visible text scan):
  Slide 36: 60K=False 1M=False 5K_lbl=False 30K=True 700K=True 3.5K=True ✓
</commit_message>
<xml_diff>
--- a/library/lectures/lec-11/rendered/lec-11.pptx
+++ b/library/lectures/lec-11/rendered/lec-11.pptx
@@ -3782,7 +3782,7 @@
           <a:p/>
           <a:p>
             <a:r>
-              <a:t>Пивоварня. Линия идёт 60 тысяч бутылок в час, миллион в сутки. Дефекты — повреждённые этикетки, кривые крышки, недолив. Доля брака примерно полпроцента. Ручной отбор на такой скорости пропускает дефекты этикеток — глаз не успевает. Периодический контроль — взяли каждую сотую, посмотрели — не покрывает все.</a:t>
+              <a:t>Пивоварня. Линия идёт 30 тысяч бутылок в час, около 700 тысяч в сутки. Дефекты — повреждённые этикетки, кривые крышки, недолив. Доля брака примерно полпроцента. Ручной отбор на такой скорости пропускает дефекты этикеток — глаз не успевает. Периодический контроль — взяли каждую сотую, посмотрели — не покрывает все.</a:t>
             </a:r>
           </a:p>
           <a:p/>
@@ -3806,7 +3806,7 @@
           <a:p/>
           <a:p>
             <a:r>
-              <a:t>Шаг третий — данные. Миллион бутылок в день, дефект полпроцента — получаем пять тысяч размеченных дефектных примеров каждый день. Класс-баланс достижим за две-три недели работы линии. Эталонная разметка дешёвая — это не рентген сварного шва, это визуально очевидные кривые этикетки или недолив. Час оператора пятьсот рублей в РФ, по сто примеров в час, расходы оценимы. Категория «данные» проходит легко.</a:t>
+              <a:t>Шаг третий — данные. Семьсот тысяч бутылок в день, дефект полпроцента — получаем три с половиной тысячи размеченных дефектных примеров каждый день. Класс-баланс за тридцать дней работы линии. Эталонная разметка дешёвая — это не рентген сварного шва, это визуально очевидные кривые этикетки или недолив. Час оператора пятьсот рублей в РФ, по сто примеров в час, расходы оценимы. Категория «данные» проходит легко.</a:t>
             </a:r>
           </a:p>
           <a:p/>
@@ -36799,7 +36799,7 @@
               <a:t>Дискретное.
 Бутылки/банки —
 штучный счёт.
-Скорость 60 000 в час.</a:t>
+Скорость 30 000 в час.</a:t>
             </a:r>
           </a:p>
         </p:txBody>
@@ -37297,9 +37297,9 @@
                 </a:solidFill>
                 <a:latin typeface="Arial"/>
               </a:rPr>
-              <a:t>&gt;1 млн бутылок/день,
-дефекты ~0,5% → 5 000 размеченных примеров в день.
-Класс-баланс достижим.</a:t>
+              <a:t>~700 000 бутылок/день,
+дефекты ~0,5% → 3 500 размеченных примеров в день.
+Класс-баланс за 30 дней.</a:t>
             </a:r>
           </a:p>
         </p:txBody>

</xml_diff>